<commit_message>
docs: record bounded live Gemini run (14/14) and update submission evidence
- New record docs/reviews/live-gemini-l1-16e31e9.md: Advisor + independent Reviewer on
  gemini-3.5-flash-lite, 4 model calls, 2 read-only evidence reads, owner-reported 14/14.
- Judge FAQ, evidence manifest, rubric map, README and live-run guide: live harness result
  replaces "not run live"; public Beta stays deterministic-only; candidate deployed with no
  traffic and smoke-tested 13/13.
- Deck slides 2, 9, 12, 13, 15: same layout, text only. Slide 1 contact still pending owner input.

No application code, release artifact or image changes.

Co-Authored-By: Claude Opus 5.5 <noreply@anthropic.com>
Claude-Session: https://claude.ai/code/session_011Rdxj7etdqG14zUJcubgxj
</commit_message>
<xml_diff>
--- a/docs/submission/assets/movebooks-final-deck.pptx
+++ b/docs/submission/assets/movebooks-final-deck.pptx
@@ -10613,7 +10613,7 @@
                 <a:ea typeface="Google Sans Flex"/>
                 <a:cs typeface="Google Sans Flex"/>
               </a:rPr>
-              <a:t>Release: proxy smoke 7/7 on a Firebase-mode build; npm and pip audits 0 known vulnerabilities. Container image scans run in Cloud Shell (pending).</a:t>
+              <a:t>Live Gemini: one bounded Advisor + Reviewer run passed 14/14 (4 model calls). Release: candidates smoke-tested 13/13; npm and pip audits 0 known vulnerabilities.</a:t>
             </a:r>
           </a:p>
         </p:txBody>
@@ -11081,7 +11081,7 @@
                 <a:ea typeface="Google Sans Flex"/>
                 <a:cs typeface="Google Sans Flex"/>
               </a:rPr>
-              <a:t>Now: run the approved bounded Gemini test, build and scan both images in Cloud Shell, deploy the candidate with no traffic and smoke-test it.</a:t>
+              <a:t>Done: bounded live Gemini test (14/14), images built and scanned, no-traffic candidates deployed and smoke-tested (13/13).</a:t>
             </a:r>
           </a:p>
         </p:txBody>
@@ -11237,7 +11237,7 @@
                 <a:ea typeface="Google Sans Flex"/>
                 <a:cs typeface="Google Sans Flex"/>
               </a:rPr>
-              <a:t>Next, release-gated: real Google sign-in and two-account isolation on the candidate, then API-first promotion with recorded rollback revisions.</a:t>
+              <a:t>Next, release-gated: database backup, API-first promotion with recorded rollback revisions, then real Google sign-in and two-account isolation.</a:t>
             </a:r>
           </a:p>
         </p:txBody>
@@ -13435,7 +13435,7 @@
                 <a:ea typeface="Google Sans Flex"/>
                 <a:cs typeface="Google Sans Flex"/>
               </a:rPr>
-              <a:t>Dormant operations resources are provisioned. Both control flags remain false. Application activation, live inference and candidate deployment require separate evidence and authorization.</a:t>
+              <a:t>Dormant operations resources are provisioned. Both control flags remain false. Live inference is verified only in a bounded test harness; activation needs separate authorization.</a:t>
             </a:r>
           </a:p>
         </p:txBody>
@@ -13978,7 +13978,7 @@
                 <a:ea typeface="Google Sans Flex Medium"/>
                 <a:cs typeface="Google Sans Flex Medium"/>
               </a:rPr>
-              <a:t>Live Gemini and operational readback remain gated.</a:t>
+              <a:t>Bounded live Gemini test passed; the public Beta stays deterministic.</a:t>
             </a:r>
             <a:endParaRPr sz="1100">
               <a:solidFill>
@@ -20738,7 +20738,7 @@
                 <a:ea typeface="Google Sans Flex"/>
                 <a:cs typeface="Google Sans Flex"/>
               </a:rPr>
-              <a:t>AI source: bounded Vertex AI / Gemini and Google ADK advisory integration. Public API remains deterministic-only; model access/lifecycle and runtime evidence are gated.</a:t>
+              <a:t>AI source: bounded Vertex AI / Gemini and Google ADK advisory integration. Public API remains deterministic-only; a bounded live run on gemini-3.5-flash-lite passed 14/14.</a:t>
             </a:r>
           </a:p>
         </p:txBody>

</xml_diff>